<commit_message>
docs(design): D02 SW 아키텍처, D03 이관 흐름도, D06 개발 일정 초안
- 문서 범위를 필수 4개로 줄이고 나머지는 작성 단계를 문서 목록에 표시(D01 확정)
- 다이어그램 모델에 자유 글·선·막대와 범례 항목 지정 추가(간트용), PPTX 도 같은 요소를 도형으로

Co-Authored-By: Claude Opus 5.5 (1M context) <noreply@anthropic.com>
Claude-Session: https://claude.ai/code/session_0127yKCBoYZqNczggAFU5LSE
</commit_message>
<xml_diff>
--- a/docs/design/dist/d01-system-architecture.pptx
+++ b/docs/design/dist/d01-system-architecture.pptx
@@ -3289,7 +3289,7 @@
           <a:p>
             <a:pPr algn="l">
               <a:lnSpc>
-                <a:spcPts val="1320"/>
+                <a:spcPts val="1200"/>
               </a:lnSpc>
             </a:pPr>
             <a:r>
@@ -3357,7 +3357,7 @@
           <a:p>
             <a:pPr algn="r">
               <a:lnSpc>
-                <a:spcPts val="1320"/>
+                <a:spcPts val="1200"/>
               </a:lnSpc>
             </a:pPr>
             <a:r>
@@ -3425,7 +3425,7 @@
           <a:p>
             <a:pPr algn="l">
               <a:lnSpc>
-                <a:spcPts val="1320"/>
+                <a:spcPts val="1200"/>
               </a:lnSpc>
             </a:pPr>
             <a:r>
@@ -19941,7 +19941,7 @@
         <p:spPr>
           <a:xfrm>
             <a:off x="381000" y="6309360"/>
-            <a:ext cx="3352800" cy="396240"/>
+            <a:ext cx="3442335" cy="396240"/>
           </a:xfrm>
           <a:prstGeom prst="roundRect">
             <a:avLst>
@@ -20004,7 +20004,7 @@
       </p:sp>
       <p:cxnSp>
         <p:nvCxnSpPr>
-          <p:cNvPr id="70" name="범례 실선"/>
+          <p:cNvPr id="70" name="범례 실시간 질의"/>
           <p:cNvCxnSpPr/>
           <p:nvPr/>
         </p:nvCxnSpPr>
@@ -20026,14 +20026,14 @@
       </p:cxnSp>
       <p:sp>
         <p:nvSpPr>
-          <p:cNvPr id="71" name="범례 실선 글"/>
+          <p:cNvPr id="71" name="범례 글 실시간 질의"/>
           <p:cNvSpPr txBox="1"/>
           <p:nvPr/>
         </p:nvSpPr>
         <p:spPr>
           <a:xfrm>
             <a:off x="1341120" y="6309360"/>
-            <a:ext cx="762000" cy="396240"/>
+            <a:ext cx="786765" cy="396240"/>
           </a:xfrm>
           <a:prstGeom prst="rect">
             <a:avLst/>
@@ -20063,13 +20063,13 @@
       </p:sp>
       <p:cxnSp>
         <p:nvCxnSpPr>
-          <p:cNvPr id="72" name="범례 점선"/>
+          <p:cNvPr id="72" name="범례 비동기 데이터 흐름"/>
           <p:cNvCxnSpPr/>
           <p:nvPr/>
         </p:nvCxnSpPr>
         <p:spPr>
           <a:xfrm>
-            <a:off x="2179320" y="6507480"/>
+            <a:off x="2204085" y="6507480"/>
             <a:ext cx="350520" cy="0"/>
           </a:xfrm>
           <a:prstGeom prst="line">
@@ -20086,14 +20086,14 @@
       </p:cxnSp>
       <p:sp>
         <p:nvSpPr>
-          <p:cNvPr id="73" name="범례 점선 글"/>
+          <p:cNvPr id="73" name="범례 글 비동기 데이터 흐름"/>
           <p:cNvSpPr txBox="1"/>
           <p:nvPr/>
         </p:nvSpPr>
         <p:spPr>
           <a:xfrm>
-            <a:off x="2606040" y="6309360"/>
-            <a:ext cx="1066800" cy="396240"/>
+            <a:off x="2630805" y="6309360"/>
+            <a:ext cx="1192530" cy="396240"/>
           </a:xfrm>
           <a:prstGeom prst="rect">
             <a:avLst/>

</xml_diff>

<commit_message>
docs(design): 설계 그림 색을 녹색 계열로(DEC-46)
Co-Authored-By: Claude Opus 5.5 (1M context) <noreply@anthropic.com>
Claude-Session: https://claude.ai/code/session_0127yKCBoYZqNczggAFU5LSE
</commit_message>
<xml_diff>
--- a/docs/design/dist/d01-system-architecture.pptx
+++ b/docs/design/dist/d01-system-architecture.pptx
@@ -3113,7 +3113,7 @@
             </a:avLst>
           </a:prstGeom>
           <a:solidFill>
-            <a:srgbClr val="1F4E8C"/>
+            <a:srgbClr val="1E6B4F"/>
           </a:solidFill>
           <a:ln>
             <a:noFill/>
@@ -3153,7 +3153,7 @@
             <a:r>
               <a:rPr sz="2160" b="1">
                 <a:solidFill>
-                  <a:srgbClr val="0B2545"/>
+                  <a:srgbClr val="0B3D2E"/>
                 </a:solidFill>
                 <a:latin typeface="Pretendard"/>
                 <a:ea typeface="Pretendard"/>
@@ -3255,11 +3255,11 @@
             </a:avLst>
           </a:prstGeom>
           <a:solidFill>
-            <a:srgbClr val="EEF6FD"/>
+            <a:srgbClr val="EEF8F3"/>
           </a:solidFill>
           <a:ln w="10668">
             <a:solidFill>
-              <a:srgbClr val="8EC3EC"/>
+              <a:srgbClr val="9DD3B8"/>
             </a:solidFill>
           </a:ln>
         </p:spPr>
@@ -3277,7 +3277,7 @@
             <a:r>
               <a:rPr sz="1200" b="1">
                 <a:solidFill>
-                  <a:srgbClr val="0B2545"/>
+                  <a:srgbClr val="0B3D2E"/>
                 </a:solidFill>
                 <a:latin typeface="Pretendard"/>
                 <a:ea typeface="Pretendard"/>
@@ -3323,11 +3323,11 @@
             </a:avLst>
           </a:prstGeom>
           <a:solidFill>
-            <a:srgbClr val="EEF6FD"/>
+            <a:srgbClr val="EEF8F3"/>
           </a:solidFill>
           <a:ln w="15240">
             <a:solidFill>
-              <a:srgbClr val="1F4E8C"/>
+              <a:srgbClr val="1E6B4F"/>
             </a:solidFill>
           </a:ln>
         </p:spPr>
@@ -3345,7 +3345,7 @@
             <a:r>
               <a:rPr sz="1200" b="1">
                 <a:solidFill>
-                  <a:srgbClr val="0B2545"/>
+                  <a:srgbClr val="0B3D2E"/>
                 </a:solidFill>
                 <a:latin typeface="Pretendard"/>
                 <a:ea typeface="Pretendard"/>
@@ -3391,11 +3391,11 @@
             </a:avLst>
           </a:prstGeom>
           <a:solidFill>
-            <a:srgbClr val="EEF6FD"/>
+            <a:srgbClr val="EEF8F3"/>
           </a:solidFill>
           <a:ln w="10668">
             <a:solidFill>
-              <a:srgbClr val="8EC3EC"/>
+              <a:srgbClr val="9DD3B8"/>
             </a:solidFill>
           </a:ln>
         </p:spPr>
@@ -3413,7 +3413,7 @@
             <a:r>
               <a:rPr sz="1200" b="1">
                 <a:solidFill>
-                  <a:srgbClr val="0B2545"/>
+                  <a:srgbClr val="0B3D2E"/>
                 </a:solidFill>
                 <a:latin typeface="Pretendard"/>
                 <a:ea typeface="Pretendard"/>
@@ -3463,7 +3463,7 @@
           </a:solidFill>
           <a:ln w="15240">
             <a:solidFill>
-              <a:srgbClr val="1F4E8C"/>
+              <a:srgbClr val="1E6B4F"/>
             </a:solidFill>
           </a:ln>
         </p:spPr>
@@ -3477,7 +3477,7 @@
             <a:r>
               <a:rPr sz="1080" b="1">
                 <a:solidFill>
-                  <a:srgbClr val="0B2545"/>
+                  <a:srgbClr val="0B3D2E"/>
                 </a:solidFill>
                 <a:latin typeface="Pretendard"/>
                 <a:ea typeface="Pretendard"/>
@@ -4697,7 +4697,7 @@
             </a:pathLst>
           </a:custGeom>
           <a:solidFill>
-            <a:srgbClr val="1F4E8C"/>
+            <a:srgbClr val="1E6B4F"/>
           </a:solidFill>
           <a:ln>
             <a:noFill/>
@@ -4732,7 +4732,7 @@
           </a:solidFill>
           <a:ln w="13716">
             <a:solidFill>
-              <a:srgbClr val="8EC3EC"/>
+              <a:srgbClr val="9DD3B8"/>
             </a:solidFill>
           </a:ln>
         </p:spPr>
@@ -4750,7 +4750,7 @@
             <a:r>
               <a:rPr sz="1200" b="1">
                 <a:solidFill>
-                  <a:srgbClr val="0B2545"/>
+                  <a:srgbClr val="0B3D2E"/>
                 </a:solidFill>
                 <a:latin typeface="Pretendard"/>
                 <a:ea typeface="Pretendard"/>
@@ -5154,7 +5154,7 @@
             </a:pathLst>
           </a:custGeom>
           <a:solidFill>
-            <a:srgbClr val="1F4E8C"/>
+            <a:srgbClr val="1E6B4F"/>
           </a:solidFill>
           <a:ln>
             <a:noFill/>
@@ -5189,7 +5189,7 @@
           </a:solidFill>
           <a:ln w="13716">
             <a:solidFill>
-              <a:srgbClr val="8EC3EC"/>
+              <a:srgbClr val="9DD3B8"/>
             </a:solidFill>
           </a:ln>
         </p:spPr>
@@ -5207,7 +5207,7 @@
             <a:r>
               <a:rPr sz="1200" b="1">
                 <a:solidFill>
-                  <a:srgbClr val="0B2545"/>
+                  <a:srgbClr val="0B3D2E"/>
                 </a:solidFill>
                 <a:latin typeface="Pretendard"/>
                 <a:ea typeface="Pretendard"/>
@@ -5617,7 +5617,7 @@
             </a:pathLst>
           </a:custGeom>
           <a:solidFill>
-            <a:srgbClr val="1F4E8C"/>
+            <a:srgbClr val="1E6B4F"/>
           </a:solidFill>
           <a:ln>
             <a:noFill/>
@@ -5652,7 +5652,7 @@
           </a:solidFill>
           <a:ln w="13716">
             <a:solidFill>
-              <a:srgbClr val="8EC3EC"/>
+              <a:srgbClr val="9DD3B8"/>
             </a:solidFill>
           </a:ln>
         </p:spPr>
@@ -5670,7 +5670,7 @@
             <a:r>
               <a:rPr sz="1200" b="1">
                 <a:solidFill>
-                  <a:srgbClr val="0B2545"/>
+                  <a:srgbClr val="0B3D2E"/>
                 </a:solidFill>
                 <a:latin typeface="Pretendard"/>
                 <a:ea typeface="Pretendard"/>
@@ -6998,7 +6998,7 @@
             </a:pathLst>
           </a:custGeom>
           <a:solidFill>
-            <a:srgbClr val="1F4E8C"/>
+            <a:srgbClr val="1E6B4F"/>
           </a:solidFill>
           <a:ln>
             <a:noFill/>
@@ -7033,7 +7033,7 @@
           </a:solidFill>
           <a:ln w="13716">
             <a:solidFill>
-              <a:srgbClr val="8EC3EC"/>
+              <a:srgbClr val="9DD3B8"/>
             </a:solidFill>
           </a:ln>
         </p:spPr>
@@ -7051,7 +7051,7 @@
             <a:r>
               <a:rPr sz="1200" b="1">
                 <a:solidFill>
-                  <a:srgbClr val="0B2545"/>
+                  <a:srgbClr val="0B3D2E"/>
                 </a:solidFill>
                 <a:latin typeface="Pretendard"/>
                 <a:ea typeface="Pretendard"/>
@@ -7255,7 +7255,7 @@
             </a:pathLst>
           </a:custGeom>
           <a:solidFill>
-            <a:srgbClr val="1F4E8C"/>
+            <a:srgbClr val="1E6B4F"/>
           </a:solidFill>
           <a:ln>
             <a:noFill/>
@@ -7284,7 +7284,7 @@
             <a:avLst/>
           </a:prstGeom>
           <a:solidFill>
-            <a:srgbClr val="1F4E8C"/>
+            <a:srgbClr val="1E6B4F"/>
           </a:solidFill>
           <a:ln>
             <a:noFill/>
@@ -7332,7 +7332,7 @@
           </a:solidFill>
           <a:ln w="13716">
             <a:solidFill>
-              <a:srgbClr val="8EC3EC"/>
+              <a:srgbClr val="9DD3B8"/>
             </a:solidFill>
           </a:ln>
         </p:spPr>
@@ -7350,7 +7350,7 @@
             <a:r>
               <a:rPr sz="1200" b="1">
                 <a:solidFill>
-                  <a:srgbClr val="0B2545"/>
+                  <a:srgbClr val="0B3D2E"/>
                 </a:solidFill>
                 <a:latin typeface="Pretendard"/>
                 <a:ea typeface="Pretendard"/>
@@ -9643,7 +9643,7 @@
             </a:pathLst>
           </a:custGeom>
           <a:solidFill>
-            <a:srgbClr val="1F4E8C"/>
+            <a:srgbClr val="1E6B4F"/>
           </a:solidFill>
           <a:ln>
             <a:noFill/>
@@ -9672,7 +9672,7 @@
             <a:avLst/>
           </a:prstGeom>
           <a:solidFill>
-            <a:srgbClr val="1F4E8C"/>
+            <a:srgbClr val="1E6B4F"/>
           </a:solidFill>
           <a:ln>
             <a:noFill/>
@@ -9716,11 +9716,11 @@
             </a:avLst>
           </a:prstGeom>
           <a:solidFill>
-            <a:srgbClr val="0B2545"/>
+            <a:srgbClr val="0B3D2E"/>
           </a:solidFill>
           <a:ln w="18288">
             <a:solidFill>
-              <a:srgbClr val="0B2545"/>
+              <a:srgbClr val="0B3D2E"/>
             </a:solidFill>
           </a:ln>
         </p:spPr>
@@ -10473,7 +10473,7 @@
             <a:r>
               <a:rPr sz="1019" b="1">
                 <a:solidFill>
-                  <a:srgbClr val="0B2545"/>
+                  <a:srgbClr val="0B3D2E"/>
                 </a:solidFill>
                 <a:latin typeface="Pretendard"/>
                 <a:ea typeface="Pretendard"/>
@@ -10505,7 +10505,7 @@
           </a:solidFill>
           <a:ln w="13716">
             <a:solidFill>
-              <a:srgbClr val="8EC3EC"/>
+              <a:srgbClr val="9DD3B8"/>
             </a:solidFill>
           </a:ln>
         </p:spPr>
@@ -10523,7 +10523,7 @@
             <a:r>
               <a:rPr sz="1200" b="1">
                 <a:solidFill>
-                  <a:srgbClr val="0B2545"/>
+                  <a:srgbClr val="0B3D2E"/>
                 </a:solidFill>
                 <a:latin typeface="Pretendard"/>
                 <a:ea typeface="Pretendard"/>
@@ -11645,7 +11645,7 @@
             </a:pathLst>
           </a:custGeom>
           <a:solidFill>
-            <a:srgbClr val="1F4E8C"/>
+            <a:srgbClr val="1E6B4F"/>
           </a:solidFill>
           <a:ln>
             <a:noFill/>
@@ -11676,11 +11676,11 @@
             </a:avLst>
           </a:prstGeom>
           <a:solidFill>
-            <a:srgbClr val="0B2545"/>
+            <a:srgbClr val="0B3D2E"/>
           </a:solidFill>
           <a:ln w="18288">
             <a:solidFill>
-              <a:srgbClr val="0B2545"/>
+              <a:srgbClr val="0B3D2E"/>
             </a:solidFill>
           </a:ln>
         </p:spPr>
@@ -12515,7 +12515,7 @@
             <a:r>
               <a:rPr sz="1019" b="1">
                 <a:solidFill>
-                  <a:srgbClr val="0B2545"/>
+                  <a:srgbClr val="0B3D2E"/>
                 </a:solidFill>
                 <a:latin typeface="Pretendard"/>
                 <a:ea typeface="Pretendard"/>
@@ -12547,7 +12547,7 @@
           </a:solidFill>
           <a:ln w="13716">
             <a:solidFill>
-              <a:srgbClr val="8EC3EC"/>
+              <a:srgbClr val="9DD3B8"/>
             </a:solidFill>
           </a:ln>
         </p:spPr>
@@ -12565,7 +12565,7 @@
             <a:r>
               <a:rPr sz="1200" b="1">
                 <a:solidFill>
-                  <a:srgbClr val="0B2545"/>
+                  <a:srgbClr val="0B3D2E"/>
                 </a:solidFill>
                 <a:latin typeface="Pretendard"/>
                 <a:ea typeface="Pretendard"/>
@@ -13017,7 +13017,7 @@
             </a:pathLst>
           </a:custGeom>
           <a:solidFill>
-            <a:srgbClr val="1F4E8C"/>
+            <a:srgbClr val="1E6B4F"/>
           </a:solidFill>
           <a:ln>
             <a:noFill/>
@@ -13046,7 +13046,7 @@
             <a:avLst/>
           </a:prstGeom>
           <a:solidFill>
-            <a:srgbClr val="1F4E8C"/>
+            <a:srgbClr val="1E6B4F"/>
           </a:solidFill>
           <a:ln>
             <a:noFill/>
@@ -13094,7 +13094,7 @@
           </a:solidFill>
           <a:ln w="13716">
             <a:solidFill>
-              <a:srgbClr val="8EC3EC"/>
+              <a:srgbClr val="9DD3B8"/>
             </a:solidFill>
           </a:ln>
         </p:spPr>
@@ -13112,7 +13112,7 @@
             <a:r>
               <a:rPr sz="1200" b="1">
                 <a:solidFill>
-                  <a:srgbClr val="0B2545"/>
+                  <a:srgbClr val="0B3D2E"/>
                 </a:solidFill>
                 <a:latin typeface="Pretendard"/>
                 <a:ea typeface="Pretendard"/>
@@ -13226,7 +13226,7 @@
             </a:pathLst>
           </a:custGeom>
           <a:solidFill>
-            <a:srgbClr val="1F4E8C"/>
+            <a:srgbClr val="1E6B4F"/>
           </a:solidFill>
           <a:ln>
             <a:noFill/>
@@ -13255,7 +13255,7 @@
             <a:avLst/>
           </a:prstGeom>
           <a:solidFill>
-            <a:srgbClr val="1F4E8C"/>
+            <a:srgbClr val="1E6B4F"/>
           </a:solidFill>
           <a:ln>
             <a:noFill/>
@@ -13303,7 +13303,7 @@
           </a:solidFill>
           <a:ln w="13716">
             <a:solidFill>
-              <a:srgbClr val="8EC3EC"/>
+              <a:srgbClr val="9DD3B8"/>
             </a:solidFill>
           </a:ln>
         </p:spPr>
@@ -13321,7 +13321,7 @@
             <a:r>
               <a:rPr sz="1200" b="1">
                 <a:solidFill>
-                  <a:srgbClr val="0B2545"/>
+                  <a:srgbClr val="0B3D2E"/>
                 </a:solidFill>
                 <a:latin typeface="Pretendard"/>
                 <a:ea typeface="Pretendard"/>
@@ -13990,7 +13990,7 @@
             </a:pathLst>
           </a:custGeom>
           <a:solidFill>
-            <a:srgbClr val="1F4E8C"/>
+            <a:srgbClr val="1E6B4F"/>
           </a:solidFill>
           <a:ln>
             <a:noFill/>
@@ -14019,7 +14019,7 @@
             <a:avLst/>
           </a:prstGeom>
           <a:solidFill>
-            <a:srgbClr val="1F4E8C"/>
+            <a:srgbClr val="1E6B4F"/>
           </a:solidFill>
           <a:ln>
             <a:noFill/>
@@ -14067,7 +14067,7 @@
           </a:solidFill>
           <a:ln w="13716">
             <a:solidFill>
-              <a:srgbClr val="8EC3EC"/>
+              <a:srgbClr val="9DD3B8"/>
             </a:solidFill>
           </a:ln>
         </p:spPr>
@@ -14085,7 +14085,7 @@
             <a:r>
               <a:rPr sz="1200" b="1">
                 <a:solidFill>
-                  <a:srgbClr val="0B2545"/>
+                  <a:srgbClr val="0B3D2E"/>
                 </a:solidFill>
                 <a:latin typeface="Pretendard"/>
                 <a:ea typeface="Pretendard"/>
@@ -14521,7 +14521,7 @@
             </a:pathLst>
           </a:custGeom>
           <a:solidFill>
-            <a:srgbClr val="1F4E8C"/>
+            <a:srgbClr val="1E6B4F"/>
           </a:solidFill>
           <a:ln>
             <a:noFill/>
@@ -14556,7 +14556,7 @@
           </a:solidFill>
           <a:ln w="13716">
             <a:solidFill>
-              <a:srgbClr val="8EC3EC"/>
+              <a:srgbClr val="9DD3B8"/>
             </a:solidFill>
           </a:ln>
         </p:spPr>
@@ -14574,7 +14574,7 @@
             <a:r>
               <a:rPr sz="1200" b="1">
                 <a:solidFill>
-                  <a:srgbClr val="0B2545"/>
+                  <a:srgbClr val="0B3D2E"/>
                 </a:solidFill>
                 <a:latin typeface="Pretendard"/>
                 <a:ea typeface="Pretendard"/>
@@ -15978,7 +15978,7 @@
             </a:pathLst>
           </a:custGeom>
           <a:solidFill>
-            <a:srgbClr val="1F4E8C"/>
+            <a:srgbClr val="1E6B4F"/>
           </a:solidFill>
           <a:ln>
             <a:noFill/>
@@ -16013,7 +16013,7 @@
           </a:solidFill>
           <a:ln w="13716">
             <a:solidFill>
-              <a:srgbClr val="8EC3EC"/>
+              <a:srgbClr val="9DD3B8"/>
             </a:solidFill>
           </a:ln>
         </p:spPr>
@@ -16031,7 +16031,7 @@
             <a:r>
               <a:rPr sz="1200" b="1">
                 <a:solidFill>
-                  <a:srgbClr val="0B2545"/>
+                  <a:srgbClr val="0B3D2E"/>
                 </a:solidFill>
                 <a:latin typeface="Pretendard"/>
                 <a:ea typeface="Pretendard"/>
@@ -16977,7 +16977,7 @@
             </a:pathLst>
           </a:custGeom>
           <a:solidFill>
-            <a:srgbClr val="1F4E8C"/>
+            <a:srgbClr val="1E6B4F"/>
           </a:solidFill>
           <a:ln>
             <a:noFill/>
@@ -17012,7 +17012,7 @@
           </a:solidFill>
           <a:ln w="13716">
             <a:solidFill>
-              <a:srgbClr val="8EC3EC"/>
+              <a:srgbClr val="9DD3B8"/>
             </a:solidFill>
           </a:ln>
         </p:spPr>
@@ -17030,7 +17030,7 @@
             <a:r>
               <a:rPr sz="1200" b="1">
                 <a:solidFill>
-                  <a:srgbClr val="0B2545"/>
+                  <a:srgbClr val="0B3D2E"/>
                 </a:solidFill>
                 <a:latin typeface="Pretendard"/>
                 <a:ea typeface="Pretendard"/>
@@ -17484,7 +17484,7 @@
             </a:pathLst>
           </a:custGeom>
           <a:solidFill>
-            <a:srgbClr val="1F4E8C"/>
+            <a:srgbClr val="1E6B4F"/>
           </a:solidFill>
           <a:ln>
             <a:noFill/>
@@ -17519,7 +17519,7 @@
           </a:solidFill>
           <a:ln w="13716">
             <a:solidFill>
-              <a:srgbClr val="8EC3EC"/>
+              <a:srgbClr val="9DD3B8"/>
             </a:solidFill>
           </a:ln>
         </p:spPr>
@@ -17537,7 +17537,7 @@
             <a:r>
               <a:rPr sz="1200" b="1">
                 <a:solidFill>
-                  <a:srgbClr val="0B2545"/>
+                  <a:srgbClr val="0B3D2E"/>
                 </a:solidFill>
                 <a:latin typeface="Pretendard"/>
                 <a:ea typeface="Pretendard"/>
@@ -19369,7 +19369,7 @@
             </a:pathLst>
           </a:custGeom>
           <a:solidFill>
-            <a:srgbClr val="1F4E8C"/>
+            <a:srgbClr val="1E6B4F"/>
           </a:solidFill>
           <a:ln>
             <a:noFill/>
@@ -19401,7 +19401,7 @@
           </a:prstGeom>
           <a:ln w="16764">
             <a:solidFill>
-              <a:srgbClr val="1F4E8C"/>
+              <a:srgbClr val="1E6B4F"/>
             </a:solidFill>
             <a:tailEnd type="triangle" w="med" len="med"/>
           </a:ln>
@@ -19435,7 +19435,7 @@
             <a:r>
               <a:rPr sz="1019" b="1">
                 <a:solidFill>
-                  <a:srgbClr val="1F4E8C"/>
+                  <a:srgbClr val="1E6B4F"/>
                 </a:solidFill>
                 <a:latin typeface="Pretendard"/>
                 <a:ea typeface="Pretendard"/>
@@ -19464,7 +19464,7 @@
           </a:prstGeom>
           <a:ln w="16764">
             <a:solidFill>
-              <a:srgbClr val="1F4E8C"/>
+              <a:srgbClr val="1E6B4F"/>
             </a:solidFill>
             <a:tailEnd type="triangle" w="med" len="med"/>
           </a:ln>
@@ -19498,7 +19498,7 @@
             <a:r>
               <a:rPr sz="1019" b="1">
                 <a:solidFill>
-                  <a:srgbClr val="1F4E8C"/>
+                  <a:srgbClr val="1E6B4F"/>
                 </a:solidFill>
                 <a:latin typeface="Pretendard"/>
                 <a:ea typeface="Pretendard"/>
@@ -19528,7 +19528,7 @@
           </a:prstGeom>
           <a:ln w="16764">
             <a:solidFill>
-              <a:srgbClr val="1F4E8C"/>
+              <a:srgbClr val="1E6B4F"/>
             </a:solidFill>
             <a:tailEnd type="triangle" w="med" len="med"/>
           </a:ln>
@@ -19562,7 +19562,7 @@
             <a:r>
               <a:rPr sz="1019" b="1">
                 <a:solidFill>
-                  <a:srgbClr val="1F4E8C"/>
+                  <a:srgbClr val="1E6B4F"/>
                 </a:solidFill>
                 <a:latin typeface="Pretendard"/>
                 <a:ea typeface="Pretendard"/>
@@ -19592,7 +19592,7 @@
           </a:prstGeom>
           <a:ln w="16764">
             <a:solidFill>
-              <a:srgbClr val="1F4E8C"/>
+              <a:srgbClr val="1E6B4F"/>
             </a:solidFill>
             <a:tailEnd type="triangle" w="med" len="med"/>
           </a:ln>
@@ -19616,7 +19616,7 @@
           </a:prstGeom>
           <a:ln w="16764">
             <a:solidFill>
-              <a:srgbClr val="1F4E8C"/>
+              <a:srgbClr val="1E6B4F"/>
             </a:solidFill>
             <a:tailEnd type="triangle" w="med" len="med"/>
           </a:ln>
@@ -19650,7 +19650,7 @@
             <a:r>
               <a:rPr sz="1019" b="1">
                 <a:solidFill>
-                  <a:srgbClr val="1F4E8C"/>
+                  <a:srgbClr val="1E6B4F"/>
                 </a:solidFill>
                 <a:latin typeface="Pretendard"/>
                 <a:ea typeface="Pretendard"/>
@@ -19680,7 +19680,7 @@
           </a:prstGeom>
           <a:ln w="16764">
             <a:solidFill>
-              <a:srgbClr val="2B86C9"/>
+              <a:srgbClr val="2E9E6E"/>
             </a:solidFill>
             <a:prstDash val="dash"/>
             <a:tailEnd type="triangle" w="med" len="med"/>
@@ -19706,7 +19706,7 @@
           </a:prstGeom>
           <a:ln w="16764">
             <a:solidFill>
-              <a:srgbClr val="2B86C9"/>
+              <a:srgbClr val="2E9E6E"/>
             </a:solidFill>
             <a:prstDash val="dash"/>
             <a:tailEnd type="triangle" w="med" len="med"/>
@@ -19741,7 +19741,7 @@
             <a:r>
               <a:rPr sz="1019" b="1">
                 <a:solidFill>
-                  <a:srgbClr val="2B86C9"/>
+                  <a:srgbClr val="2E9E6E"/>
                 </a:solidFill>
                 <a:latin typeface="Pretendard"/>
                 <a:ea typeface="Pretendard"/>
@@ -19771,7 +19771,7 @@
           </a:prstGeom>
           <a:ln w="16764">
             <a:solidFill>
-              <a:srgbClr val="2B86C9"/>
+              <a:srgbClr val="2E9E6E"/>
             </a:solidFill>
             <a:prstDash val="dash"/>
             <a:tailEnd type="triangle" w="med" len="med"/>
@@ -19797,7 +19797,7 @@
           </a:prstGeom>
           <a:ln w="16764">
             <a:solidFill>
-              <a:srgbClr val="2B86C9"/>
+              <a:srgbClr val="2E9E6E"/>
             </a:solidFill>
             <a:prstDash val="dash"/>
             <a:tailEnd type="triangle" w="med" len="med"/>
@@ -19822,7 +19822,7 @@
           </a:prstGeom>
           <a:ln w="16764">
             <a:solidFill>
-              <a:srgbClr val="2B86C9"/>
+              <a:srgbClr val="2E9E6E"/>
             </a:solidFill>
             <a:prstDash val="dash"/>
             <a:tailEnd type="triangle" w="med" len="med"/>
@@ -19857,7 +19857,7 @@
             <a:r>
               <a:rPr sz="1019" b="1">
                 <a:solidFill>
-                  <a:srgbClr val="2B86C9"/>
+                  <a:srgbClr val="2E9E6E"/>
                 </a:solidFill>
                 <a:latin typeface="Pretendard"/>
                 <a:ea typeface="Pretendard"/>
@@ -19887,7 +19887,7 @@
           </a:prstGeom>
           <a:ln w="16764">
             <a:solidFill>
-              <a:srgbClr val="1F4E8C"/>
+              <a:srgbClr val="1E6B4F"/>
             </a:solidFill>
             <a:tailEnd type="triangle" w="med" len="med"/>
           </a:ln>
@@ -19921,7 +19921,7 @@
             <a:r>
               <a:rPr sz="1019" b="1">
                 <a:solidFill>
-                  <a:srgbClr val="1F4E8C"/>
+                  <a:srgbClr val="1E6B4F"/>
                 </a:solidFill>
                 <a:latin typeface="Pretendard"/>
                 <a:ea typeface="Pretendard"/>
@@ -19953,7 +19953,7 @@
           </a:solidFill>
           <a:ln w="10668">
             <a:solidFill>
-              <a:srgbClr val="8EC3EC"/>
+              <a:srgbClr val="9DD3B8"/>
             </a:solidFill>
           </a:ln>
         </p:spPr>
@@ -19991,7 +19991,7 @@
             <a:r>
               <a:rPr sz="1019" b="1">
                 <a:solidFill>
-                  <a:srgbClr val="0B2545"/>
+                  <a:srgbClr val="0B3D2E"/>
                 </a:solidFill>
                 <a:latin typeface="Pretendard"/>
                 <a:ea typeface="Pretendard"/>
@@ -20018,7 +20018,7 @@
           </a:prstGeom>
           <a:ln w="16764">
             <a:solidFill>
-              <a:srgbClr val="1F4E8C"/>
+              <a:srgbClr val="1E6B4F"/>
             </a:solidFill>
             <a:tailEnd type="triangle" w="med" len="med"/>
           </a:ln>
@@ -20077,7 +20077,7 @@
           </a:prstGeom>
           <a:ln w="16764">
             <a:solidFill>
-              <a:srgbClr val="2B86C9"/>
+              <a:srgbClr val="2E9E6E"/>
             </a:solidFill>
             <a:prstDash val="dash"/>
             <a:tailEnd type="triangle" w="med" len="med"/>

</xml_diff>